<commit_message>
chore: migrate live domain and presentation links to ziv-1304.web.app
</commit_message>
<xml_diff>
--- a/Ziv_Project_Presentation.pptx
+++ b/Ziv_Project_Presentation.pptx
@@ -3241,7 +3241,7 @@
               </a:defRPr>
             </a:pPr>
             <a:r>
-              <a:t>Presented By: Engineering Project Team  •  Live Demo: https://doap-1908.web.app</a:t>
+              <a:t>Presented By: Engineering Project Team  •  Live Demo: https://ziv-1304.web.app</a:t>
             </a:r>
           </a:p>
         </p:txBody>
@@ -5845,7 +5845,7 @@
               </a:defRPr>
             </a:pPr>
             <a:r>
-              <a:t>• Live Working URL: https://doap-1908.web.app</a:t>
+              <a:t>• Live Working URL: https://ziv-1304.web.app</a:t>
             </a:r>
           </a:p>
           <a:p>

</xml_diff>